<commit_message>
FGD deck: write MERALCO in capitals
Co-Authored-By: Claude Opus 5.5 <noreply@anthropic.com>
Claude-Session: https://claude.ai/code/session_01J6VUATAmWPQdQ6XxJGJU7F
</commit_message>
<xml_diff>
--- a/ERC_FGD_Model_Assumptions.pptx
+++ b/ERC_FGD_Model_Assumptions.pptx
@@ -1307,7 +1307,7 @@
           <a:p>
             <a:r>
               <a:rPr lang="en-US" dirty="0"/>
-              <a:t>Capacity factor drives energy, so it matters most. Case A uses 42 percent, the top of the TOR band. Case B uses what the gas fleet actually ran: 66.8 percent for existing plants and 63.1 percent for the whole fleet, from Meralco's published generation-charge data. For Lot 1 we add 24 percent non-mid-merit energy, which the TOR pays at Fuel Cost only. Capacity factors are net, so no separate own-use deduction. Output degrades 0.2 percent a year.</a:t>
+              <a:t>Capacity factor drives energy, so it matters most. Case A uses 42 percent, the top of the TOR band. Case B uses what the gas fleet actually ran: 66.8 percent for existing plants and 63.1 percent for the whole fleet, from MERALCO's published generation-charge data. For Lot 1 we add 24 percent non-mid-merit energy, which the TOR pays at Fuel Cost only. Capacity factors are net, so no separate own-use deduction. Output degrades 0.2 percent a year.</a:t>
             </a:r>
             <a:endParaRPr lang="en-US" dirty="0"/>
           </a:p>
@@ -13116,7 +13116,7 @@
                   <a:schemeClr val="accent4"/>
                 </a:solidFill>
               </a:rPr>
-              <a:t>Case B source: Meralco “Breakdown of Generation Charge” tables (plants supplying Meralco), Jan 2024–Sep 2026.</a:t>
+              <a:t>Case B source: MERALCO “Breakdown of Generation Charge” tables (plants supplying MERALCO), Jan 2024–Sep 2026.</a:t>
             </a:r>
             <a:endParaRPr lang="en-US" sz="1200" dirty="0"/>
           </a:p>

</xml_diff>